<commit_message>
Vecka 45: figurer och texträttelser (före granskning)
Co-Authored-By: Claude Opus 5.5 <noreply@anthropic.com>
Claude-Session: https://claude.ai/code/session_011V9KjBb53XrDm23Dw58SH3
</commit_message>
<xml_diff>
--- a/sjoskolan/vecka-45/aktuell/v45_01_Systematisk_felsokning_elev.pptx
+++ b/sjoskolan/vecka-45/aktuell/v45_01_Systematisk_felsokning_elev.pptx
@@ -6037,7 +6037,117 @@
                 <a:ea typeface="Calibri"/>
                 <a:cs typeface="Calibri"/>
               </a:rPr>
-              <a:t>Uresistor = R · I     Ukontakt = Ukälla − Uresistor</a:t>
+              <a:t>U</a:t>
+            </a:r>
+            <a:r>
+              <a:rPr sz="2400" b="1" baseline="-25000">
+                <a:solidFill>
+                  <a:srgbClr val="064F91"/>
+                </a:solidFill>
+                <a:latin typeface="Calibri"/>
+                <a:ea typeface="Calibri"/>
+                <a:cs typeface="Calibri"/>
+              </a:rPr>
+              <a:t>resistor</a:t>
+            </a:r>
+            <a:r>
+              <a:rPr sz="2400" b="1">
+                <a:solidFill>
+                  <a:srgbClr val="064F91"/>
+                </a:solidFill>
+                <a:latin typeface="Calibri"/>
+                <a:ea typeface="Calibri"/>
+                <a:cs typeface="Calibri"/>
+              </a:rPr>
+              <a:t> = R · I     </a:t>
+            </a:r>
+            <a:r>
+              <a:rPr sz="2400" b="1">
+                <a:solidFill>
+                  <a:srgbClr val="064F91"/>
+                </a:solidFill>
+                <a:latin typeface="Calibri"/>
+                <a:ea typeface="Calibri"/>
+                <a:cs typeface="Calibri"/>
+              </a:rPr>
+              <a:t>U</a:t>
+            </a:r>
+            <a:r>
+              <a:rPr sz="2400" b="1" baseline="-25000">
+                <a:solidFill>
+                  <a:srgbClr val="064F91"/>
+                </a:solidFill>
+                <a:latin typeface="Calibri"/>
+                <a:ea typeface="Calibri"/>
+                <a:cs typeface="Calibri"/>
+              </a:rPr>
+              <a:t>kontakt</a:t>
+            </a:r>
+            <a:r>
+              <a:rPr sz="2400" b="1">
+                <a:solidFill>
+                  <a:srgbClr val="064F91"/>
+                </a:solidFill>
+                <a:latin typeface="Calibri"/>
+                <a:ea typeface="Calibri"/>
+                <a:cs typeface="Calibri"/>
+              </a:rPr>
+              <a:t> = </a:t>
+            </a:r>
+            <a:r>
+              <a:rPr sz="2400" b="1">
+                <a:solidFill>
+                  <a:srgbClr val="064F91"/>
+                </a:solidFill>
+                <a:latin typeface="Calibri"/>
+                <a:ea typeface="Calibri"/>
+                <a:cs typeface="Calibri"/>
+              </a:rPr>
+              <a:t>U</a:t>
+            </a:r>
+            <a:r>
+              <a:rPr sz="2400" b="1" baseline="-25000">
+                <a:solidFill>
+                  <a:srgbClr val="064F91"/>
+                </a:solidFill>
+                <a:latin typeface="Calibri"/>
+                <a:ea typeface="Calibri"/>
+                <a:cs typeface="Calibri"/>
+              </a:rPr>
+              <a:t>källa</a:t>
+            </a:r>
+            <a:r>
+              <a:rPr sz="2400" b="1">
+                <a:solidFill>
+                  <a:srgbClr val="064F91"/>
+                </a:solidFill>
+                <a:latin typeface="Calibri"/>
+                <a:ea typeface="Calibri"/>
+                <a:cs typeface="Calibri"/>
+              </a:rPr>
+              <a:t> − </a:t>
+            </a:r>
+            <a:r>
+              <a:rPr sz="2400" b="1">
+                <a:solidFill>
+                  <a:srgbClr val="064F91"/>
+                </a:solidFill>
+                <a:latin typeface="Calibri"/>
+                <a:ea typeface="Calibri"/>
+                <a:cs typeface="Calibri"/>
+              </a:rPr>
+              <a:t>U</a:t>
+            </a:r>
+            <a:r>
+              <a:rPr sz="2400" b="1" baseline="-25000">
+                <a:solidFill>
+                  <a:srgbClr val="064F91"/>
+                </a:solidFill>
+                <a:latin typeface="Calibri"/>
+                <a:ea typeface="Calibri"/>
+                <a:cs typeface="Calibri"/>
+              </a:rPr>
+              <a:t>resistor</a:t>
             </a:r>
           </a:p>
         </p:txBody>
@@ -6449,7 +6559,7 @@
         <p:spPr>
           <a:xfrm xmlns:a="http://schemas.openxmlformats.org/drawingml/2006/main">
             <a:off x="762000" y="2533650"/>
-            <a:ext cx="7620000" cy="2286000"/>
+            <a:ext cx="3886200" cy="2606040"/>
           </a:xfrm>
           <a:prstGeom xmlns:a="http://schemas.openxmlformats.org/drawingml/2006/main" prst="rect">
             <a:avLst/>
@@ -6485,7 +6595,7 @@
                 <a:ea typeface="Calibri"/>
                 <a:cs typeface="Calibri"/>
               </a:rPr>
-              <a:t>24 V matar en resistor via en enda öppen kontakt. Returen är hel. Vilken ström går, och vilken ideal spänning ligger över kontakten?</a:t>
+              <a:t>24 V matar en resistor via en enda öppen kontakt. Returen är hel. Vilken ström går, och vilken ideal spänning ligger över kontakten?</a:t>
             </a:r>
           </a:p>
         </p:txBody>
@@ -6606,6 +6716,30 @@
           </a:p>
         </p:txBody>
       </p:sp>
+      <p:pic xmlns:a="http://schemas.openxmlformats.org/drawingml/2006/main" xmlns:r="http://schemas.openxmlformats.org/officeDocument/2006/relationships">
+        <p:nvPicPr>
+          <p:cNvPr id="9" name="Figur: 24 V matar en resistor via en öppen kont" descr="24 V matar en resistor via en öppen kontakt; ström och spänning över kontakten okända"/>
+          <p:cNvPicPr>
+            <a:picLocks noChangeAspect="1"/>
+          </p:cNvPicPr>
+          <p:nvPr/>
+        </p:nvPicPr>
+        <p:blipFill>
+          <a:blip r:embed="rId3"/>
+          <a:stretch>
+            <a:fillRect/>
+          </a:stretch>
+        </p:blipFill>
+        <p:spPr>
+          <a:xfrm>
+            <a:off x="4846320" y="2331720"/>
+            <a:ext cx="3931920" cy="2740984"/>
+          </a:xfrm>
+          <a:prstGeom prst="rect">
+            <a:avLst/>
+          </a:prstGeom>
+        </p:spPr>
+      </p:pic>
     </p:spTree>
     <p:extLst>
       <p:ext uri="{BB962C8B-B14F-4D97-AF65-F5344CB8AC3E}">
@@ -6761,7 +6895,29 @@
                 <a:ea typeface="Calibri"/>
                 <a:cs typeface="Calibri"/>
               </a:rPr>
-              <a:t>I = U/Rtotal</a:t>
+              <a:t>I = U/</a:t>
+            </a:r>
+            <a:r>
+              <a:rPr sz="2400" b="1">
+                <a:solidFill>
+                  <a:srgbClr val="064F91"/>
+                </a:solidFill>
+                <a:latin typeface="Calibri"/>
+                <a:ea typeface="Calibri"/>
+                <a:cs typeface="Calibri"/>
+              </a:rPr>
+              <a:t>R</a:t>
+            </a:r>
+            <a:r>
+              <a:rPr sz="2400" b="1" baseline="-25000">
+                <a:solidFill>
+                  <a:srgbClr val="064F91"/>
+                </a:solidFill>
+                <a:latin typeface="Calibri"/>
+                <a:ea typeface="Calibri"/>
+                <a:cs typeface="Calibri"/>
+              </a:rPr>
+              <a:t>total</a:t>
             </a:r>
           </a:p>
         </p:txBody>
@@ -6818,7 +6974,29 @@
                 <a:ea typeface="Calibri"/>
                 <a:cs typeface="Calibri"/>
               </a:rPr>
-              <a:t>Rtotal omfattar hela den oavsiktliga strömvägen i modellen. V/Ω ger A.</a:t>
+              <a:t>R</a:t>
+            </a:r>
+            <a:r>
+              <a:rPr sz="2100" b="0" baseline="-25000">
+                <a:solidFill>
+                  <a:srgbClr val="111111"/>
+                </a:solidFill>
+                <a:latin typeface="Calibri"/>
+                <a:ea typeface="Calibri"/>
+                <a:cs typeface="Calibri"/>
+              </a:rPr>
+              <a:t>total</a:t>
+            </a:r>
+            <a:r>
+              <a:rPr sz="2100" b="0">
+                <a:solidFill>
+                  <a:srgbClr val="111111"/>
+                </a:solidFill>
+                <a:latin typeface="Calibri"/>
+                <a:ea typeface="Calibri"/>
+                <a:cs typeface="Calibri"/>
+              </a:rPr>
+              <a:t> omfattar hela den oavsiktliga strömvägen i modellen. V/Ω ger A.</a:t>
             </a:r>
           </a:p>
         </p:txBody>
@@ -8755,7 +8933,7 @@
                 <a:ea typeface="Calibri"/>
                 <a:cs typeface="Calibri"/>
               </a:rPr>
-              <a:t>0,20 Ω vid 10 A ger 2 V fall och 20 W värme.</a:t>
+              <a:t>0,15 Ω vid 8 A ger 1,2 V fall och 9,6 W värme.</a:t>
             </a:r>
           </a:p>
           <a:p xmlns:a="http://schemas.openxmlformats.org/drawingml/2006/main">
@@ -9139,7 +9317,7 @@
                 <a:ea typeface="Calibri"/>
                 <a:cs typeface="Calibri"/>
               </a:rPr>
-              <a:t>Normal spolspänning under START men bortfall efter släpp</a:t>
+              <a:t>Välj en mätpunkt och ett driftläge där de två hypoteserna</a:t>
             </a:r>
           </a:p>
           <a:p xmlns:a="http://schemas.openxmlformats.org/drawingml/2006/main">
@@ -9163,7 +9341,7 @@
                 <a:ea typeface="Calibri"/>
                 <a:cs typeface="Calibri"/>
               </a:rPr>
-              <a:t>pekar mot hållfunktionen. Nästa kontroll prövar den vägen.</a:t>
+              <a:t>förutsäger olika värden. Skriv förväntat värde före mätningen.</a:t>
             </a:r>
           </a:p>
         </p:txBody>
@@ -9346,7 +9524,7 @@
         <p:spPr>
           <a:xfrm xmlns:a="http://schemas.openxmlformats.org/drawingml/2006/main">
             <a:off x="762000" y="1571625"/>
-            <a:ext cx="7620000" cy="990600"/>
+            <a:ext cx="3977639" cy="990600"/>
           </a:xfrm>
           <a:prstGeom xmlns:a="http://schemas.openxmlformats.org/drawingml/2006/main" prst="rect">
             <a:avLst/>
@@ -9373,15 +9551,15 @@
               </a:defRPr>
             </a:pPr>
             <a:r>
-              <a:rPr sz="2175" b="0">
-                <a:solidFill>
-                  <a:srgbClr val="111111"/>
-                </a:solidFill>
-                <a:latin typeface="Calibri"/>
-                <a:ea typeface="Calibri"/>
-                <a:cs typeface="Calibri"/>
-              </a:rPr>
-              <a:t>Källan håller 12 V under last. Lasten får 10 V vid 2 A. Övriga fall försummas.</a:t>
+              <a:rPr sz="2100" b="0">
+                <a:solidFill>
+                  <a:srgbClr val="111111"/>
+                </a:solidFill>
+                <a:latin typeface="Calibri"/>
+                <a:ea typeface="Calibri"/>
+                <a:cs typeface="Calibri"/>
+              </a:rPr>
+              <a:t>Källan håller 12 V under last. Lasten får 10 V vid 2 A. Övriga fall försummas.</a:t>
             </a:r>
           </a:p>
         </p:txBody>
@@ -9403,7 +9581,7 @@
         <p:spPr>
           <a:xfrm xmlns:a="http://schemas.openxmlformats.org/drawingml/2006/main">
             <a:off x="762000" y="2705100"/>
-            <a:ext cx="7620000" cy="790575"/>
+            <a:ext cx="3977639" cy="790575"/>
           </a:xfrm>
           <a:prstGeom xmlns:a="http://schemas.openxmlformats.org/drawingml/2006/main" prst="rect">
             <a:avLst/>
@@ -9438,7 +9616,95 @@
                 <a:ea typeface="Calibri"/>
                 <a:cs typeface="Calibri"/>
               </a:rPr>
-              <a:t>Rextra = (Ukälla − Ulast)/I     P = I²Rextra</a:t>
+              <a:t>R</a:t>
+            </a:r>
+            <a:r>
+              <a:rPr sz="2325" b="1" baseline="-25000">
+                <a:solidFill>
+                  <a:srgbClr val="064F91"/>
+                </a:solidFill>
+                <a:latin typeface="Calibri"/>
+                <a:ea typeface="Calibri"/>
+                <a:cs typeface="Calibri"/>
+              </a:rPr>
+              <a:t>extra</a:t>
+            </a:r>
+            <a:r>
+              <a:rPr sz="2325" b="1">
+                <a:solidFill>
+                  <a:srgbClr val="064F91"/>
+                </a:solidFill>
+                <a:latin typeface="Calibri"/>
+                <a:ea typeface="Calibri"/>
+                <a:cs typeface="Calibri"/>
+              </a:rPr>
+              <a:t> = (</a:t>
+            </a:r>
+            <a:r>
+              <a:rPr sz="2325" b="1">
+                <a:solidFill>
+                  <a:srgbClr val="064F91"/>
+                </a:solidFill>
+                <a:latin typeface="Calibri"/>
+                <a:ea typeface="Calibri"/>
+                <a:cs typeface="Calibri"/>
+              </a:rPr>
+              <a:t>U</a:t>
+            </a:r>
+            <a:r>
+              <a:rPr sz="2325" b="1" baseline="-25000">
+                <a:solidFill>
+                  <a:srgbClr val="064F91"/>
+                </a:solidFill>
+                <a:latin typeface="Calibri"/>
+                <a:ea typeface="Calibri"/>
+                <a:cs typeface="Calibri"/>
+              </a:rPr>
+              <a:t>källa</a:t>
+            </a:r>
+            <a:r>
+              <a:rPr sz="2325" b="1">
+                <a:solidFill>
+                  <a:srgbClr val="064F91"/>
+                </a:solidFill>
+                <a:latin typeface="Calibri"/>
+                <a:ea typeface="Calibri"/>
+                <a:cs typeface="Calibri"/>
+              </a:rPr>
+              <a:t> − </a:t>
+            </a:r>
+            <a:r>
+              <a:rPr sz="2325" b="1">
+                <a:solidFill>
+                  <a:srgbClr val="064F91"/>
+                </a:solidFill>
+                <a:latin typeface="Calibri"/>
+                <a:ea typeface="Calibri"/>
+                <a:cs typeface="Calibri"/>
+              </a:rPr>
+              <a:t>U</a:t>
+            </a:r>
+            <a:r>
+              <a:rPr sz="2325" b="1" baseline="-25000">
+                <a:solidFill>
+                  <a:srgbClr val="064F91"/>
+                </a:solidFill>
+                <a:latin typeface="Calibri"/>
+                <a:ea typeface="Calibri"/>
+                <a:cs typeface="Calibri"/>
+              </a:rPr>
+              <a:t>last</a:t>
+            </a:r>
+            <a:r>
+              <a:rPr sz="2325" b="1">
+                <a:solidFill>
+                  <a:srgbClr val="064F91"/>
+                </a:solidFill>
+                <a:latin typeface="Calibri"/>
+                <a:ea typeface="Calibri"/>
+                <a:cs typeface="Calibri"/>
+              </a:rPr>
+              <a:t>)/I     P = I²Rextra</a:t>
             </a:r>
           </a:p>
         </p:txBody>
@@ -9460,7 +9726,7 @@
         <p:spPr>
           <a:xfrm xmlns:a="http://schemas.openxmlformats.org/drawingml/2006/main">
             <a:off x="762000" y="3657600"/>
-            <a:ext cx="7620000" cy="1524000"/>
+            <a:ext cx="3977639" cy="1524000"/>
           </a:xfrm>
           <a:prstGeom xmlns:a="http://schemas.openxmlformats.org/drawingml/2006/main" prst="rect">
             <a:avLst/>
@@ -9495,7 +9761,7 @@
                 <a:ea typeface="Calibri"/>
                 <a:cs typeface="Calibri"/>
               </a:rPr>
-              <a:t>1. ΔU = 12 − 10 = 2 V.</a:t>
+              <a:t>1. ΔU = 12 − 10 = 2 V.</a:t>
             </a:r>
           </a:p>
           <a:p xmlns:a="http://schemas.openxmlformats.org/drawingml/2006/main">
@@ -9518,7 +9784,40 @@
                 <a:ea typeface="Calibri"/>
                 <a:cs typeface="Calibri"/>
               </a:rPr>
-              <a:t>2. Rextra = 2/2 = 1 Ω.</a:t>
+              <a:t>2. </a:t>
+            </a:r>
+            <a:r>
+              <a:rPr sz="2063" b="0">
+                <a:solidFill>
+                  <a:srgbClr val="111111"/>
+                </a:solidFill>
+                <a:latin typeface="Calibri"/>
+                <a:ea typeface="Calibri"/>
+                <a:cs typeface="Calibri"/>
+              </a:rPr>
+              <a:t>R</a:t>
+            </a:r>
+            <a:r>
+              <a:rPr sz="2063" b="0" baseline="-25000">
+                <a:solidFill>
+                  <a:srgbClr val="111111"/>
+                </a:solidFill>
+                <a:latin typeface="Calibri"/>
+                <a:ea typeface="Calibri"/>
+                <a:cs typeface="Calibri"/>
+              </a:rPr>
+              <a:t>extra</a:t>
+            </a:r>
+            <a:r>
+              <a:rPr sz="2063" b="0">
+                <a:solidFill>
+                  <a:srgbClr val="111111"/>
+                </a:solidFill>
+                <a:latin typeface="Calibri"/>
+                <a:ea typeface="Calibri"/>
+                <a:cs typeface="Calibri"/>
+              </a:rPr>
+              <a:t> = 2/2 = 1 Ω.</a:t>
             </a:r>
           </a:p>
           <a:p xmlns:a="http://schemas.openxmlformats.org/drawingml/2006/main">
@@ -9541,7 +9840,7 @@
                 <a:ea typeface="Calibri"/>
                 <a:cs typeface="Calibri"/>
               </a:rPr>
-              <a:t>3. P = 2² · 1 = 4 W i den extra resistansen.</a:t>
+              <a:t>3. P = 2² · 1 = 4 W i den extra resistansen.</a:t>
             </a:r>
           </a:p>
         </p:txBody>
@@ -9563,7 +9862,7 @@
         <p:spPr>
           <a:xfrm xmlns:a="http://schemas.openxmlformats.org/drawingml/2006/main">
             <a:off x="762000" y="5372100"/>
-            <a:ext cx="7620000" cy="685800"/>
+            <a:ext cx="3977639" cy="685800"/>
           </a:xfrm>
           <a:prstGeom xmlns:a="http://schemas.openxmlformats.org/drawingml/2006/main" prst="rect">
             <a:avLst/>
@@ -9590,15 +9889,15 @@
               </a:defRPr>
             </a:pPr>
             <a:r>
-              <a:rPr sz="1913" b="0">
-                <a:solidFill>
-                  <a:srgbClr val="111111"/>
-                </a:solidFill>
-                <a:latin typeface="Calibri"/>
-                <a:ea typeface="Calibri"/>
-                <a:cs typeface="Calibri"/>
-              </a:rPr>
-              <a:t>Kontroll: ΔU · I = 2 · 2 = 4 W. Tomgång kan dölja fallet eftersom strömmen då är liten.</a:t>
+              <a:rPr sz="1550" b="0">
+                <a:solidFill>
+                  <a:srgbClr val="111111"/>
+                </a:solidFill>
+                <a:latin typeface="Calibri"/>
+                <a:ea typeface="Calibri"/>
+                <a:cs typeface="Calibri"/>
+              </a:rPr>
+              <a:t>Kontroll: ΔU · I = 2 · 2 = 4 W. Tomgång kan dölja fallet eftersom strömmen då är liten.</a:t>
             </a:r>
           </a:p>
         </p:txBody>
@@ -9660,6 +9959,30 @@
           </a:p>
         </p:txBody>
       </p:sp>
+      <p:pic xmlns:a="http://schemas.openxmlformats.org/drawingml/2006/main" xmlns:r="http://schemas.openxmlformats.org/officeDocument/2006/relationships">
+        <p:nvPicPr>
+          <p:cNvPr id="16" name="Figur: 12 V-källa, extra serieresistans 1 ohm o" descr="12 V-källa, extra serieresistans 1 ohm och last med 10 V vid 2 A"/>
+          <p:cNvPicPr>
+            <a:picLocks noChangeAspect="1"/>
+          </p:cNvPicPr>
+          <p:nvPr/>
+        </p:nvPicPr>
+        <p:blipFill>
+          <a:blip r:embed="rId3"/>
+          <a:stretch>
+            <a:fillRect/>
+          </a:stretch>
+        </p:blipFill>
+        <p:spPr>
+          <a:xfrm>
+            <a:off x="4892040" y="1645920"/>
+            <a:ext cx="3886200" cy="2709112"/>
+          </a:xfrm>
+          <a:prstGeom prst="rect">
+            <a:avLst/>
+          </a:prstGeom>
+        </p:spPr>
+      </p:pic>
     </p:spTree>
     <p:extLst>
       <p:ext uri="{BB962C8B-B14F-4D97-AF65-F5344CB8AC3E}">
@@ -10539,7 +10862,106 @@
                 <a:ea typeface="Calibri"/>
                 <a:cs typeface="Calibri"/>
               </a:rPr>
-              <a:t>ΔU = Ukälla − Ulast     Rextra = ΔU/I</a:t>
+              <a:t>ΔU = </a:t>
+            </a:r>
+            <a:r>
+              <a:rPr sz="2400" b="1">
+                <a:solidFill>
+                  <a:srgbClr val="064F91"/>
+                </a:solidFill>
+                <a:latin typeface="Calibri"/>
+                <a:ea typeface="Calibri"/>
+                <a:cs typeface="Calibri"/>
+              </a:rPr>
+              <a:t>U</a:t>
+            </a:r>
+            <a:r>
+              <a:rPr sz="2400" b="1" baseline="-25000">
+                <a:solidFill>
+                  <a:srgbClr val="064F91"/>
+                </a:solidFill>
+                <a:latin typeface="Calibri"/>
+                <a:ea typeface="Calibri"/>
+                <a:cs typeface="Calibri"/>
+              </a:rPr>
+              <a:t>källa</a:t>
+            </a:r>
+            <a:r>
+              <a:rPr sz="2400" b="1">
+                <a:solidFill>
+                  <a:srgbClr val="064F91"/>
+                </a:solidFill>
+                <a:latin typeface="Calibri"/>
+                <a:ea typeface="Calibri"/>
+                <a:cs typeface="Calibri"/>
+              </a:rPr>
+              <a:t> − </a:t>
+            </a:r>
+            <a:r>
+              <a:rPr sz="2400" b="1">
+                <a:solidFill>
+                  <a:srgbClr val="064F91"/>
+                </a:solidFill>
+                <a:latin typeface="Calibri"/>
+                <a:ea typeface="Calibri"/>
+                <a:cs typeface="Calibri"/>
+              </a:rPr>
+              <a:t>U</a:t>
+            </a:r>
+            <a:r>
+              <a:rPr sz="2400" b="1" baseline="-25000">
+                <a:solidFill>
+                  <a:srgbClr val="064F91"/>
+                </a:solidFill>
+                <a:latin typeface="Calibri"/>
+                <a:ea typeface="Calibri"/>
+                <a:cs typeface="Calibri"/>
+              </a:rPr>
+              <a:t>last</a:t>
+            </a:r>
+            <a:r>
+              <a:rPr sz="2400" b="1">
+                <a:solidFill>
+                  <a:srgbClr val="064F91"/>
+                </a:solidFill>
+                <a:latin typeface="Calibri"/>
+                <a:ea typeface="Calibri"/>
+                <a:cs typeface="Calibri"/>
+              </a:rPr>
+              <a:t>     </a:t>
+            </a:r>
+            <a:r>
+              <a:rPr sz="2400" b="1">
+                <a:solidFill>
+                  <a:srgbClr val="064F91"/>
+                </a:solidFill>
+                <a:latin typeface="Calibri"/>
+                <a:ea typeface="Calibri"/>
+                <a:cs typeface="Calibri"/>
+              </a:rPr>
+              <a:t>R</a:t>
+            </a:r>
+            <a:r>
+              <a:rPr sz="2400" b="1" baseline="-25000">
+                <a:solidFill>
+                  <a:srgbClr val="064F91"/>
+                </a:solidFill>
+                <a:latin typeface="Calibri"/>
+                <a:ea typeface="Calibri"/>
+                <a:cs typeface="Calibri"/>
+              </a:rPr>
+              <a:t>extra</a:t>
+            </a:r>
+            <a:r>
+              <a:rPr sz="2400" b="1">
+                <a:solidFill>
+                  <a:srgbClr val="064F91"/>
+                </a:solidFill>
+                <a:latin typeface="Calibri"/>
+                <a:ea typeface="Calibri"/>
+                <a:cs typeface="Calibri"/>
+              </a:rPr>
+              <a:t> = ΔU/I</a:t>
             </a:r>
           </a:p>
         </p:txBody>
@@ -10653,7 +11075,40 @@
                 <a:ea typeface="Calibri"/>
                 <a:cs typeface="Calibri"/>
               </a:rPr>
-              <a:t>Förutsättningar: Källan håller 24 V under last. Ulast = 18 V och I = 3 A. Övriga seriefall försummas.</a:t>
+              <a:t>Förutsättningar: Källan håller 24 V under last. </a:t>
+            </a:r>
+            <a:r>
+              <a:rPr sz="2025" b="0">
+                <a:solidFill>
+                  <a:srgbClr val="111111"/>
+                </a:solidFill>
+                <a:latin typeface="Calibri"/>
+                <a:ea typeface="Calibri"/>
+                <a:cs typeface="Calibri"/>
+              </a:rPr>
+              <a:t>U</a:t>
+            </a:r>
+            <a:r>
+              <a:rPr sz="2025" b="0" baseline="-25000">
+                <a:solidFill>
+                  <a:srgbClr val="111111"/>
+                </a:solidFill>
+                <a:latin typeface="Calibri"/>
+                <a:ea typeface="Calibri"/>
+                <a:cs typeface="Calibri"/>
+              </a:rPr>
+              <a:t>last</a:t>
+            </a:r>
+            <a:r>
+              <a:rPr sz="2025" b="0">
+                <a:solidFill>
+                  <a:srgbClr val="111111"/>
+                </a:solidFill>
+                <a:latin typeface="Calibri"/>
+                <a:ea typeface="Calibri"/>
+                <a:cs typeface="Calibri"/>
+              </a:rPr>
+              <a:t> = 18 V och I = 3 A. Övriga seriefall försummas.</a:t>
             </a:r>
           </a:p>
         </p:txBody>
@@ -10951,7 +11406,7 @@
         <p:spPr>
           <a:xfrm xmlns:a="http://schemas.openxmlformats.org/drawingml/2006/main">
             <a:off x="762000" y="2533650"/>
-            <a:ext cx="7620000" cy="2286000"/>
+            <a:ext cx="3886200" cy="2606040"/>
           </a:xfrm>
           <a:prstGeom xmlns:a="http://schemas.openxmlformats.org/drawingml/2006/main" prst="rect">
             <a:avLst/>
@@ -10987,7 +11442,7 @@
                 <a:ea typeface="Calibri"/>
                 <a:cs typeface="Calibri"/>
               </a:rPr>
-              <a:t>Matningen mäts till 24 V utan last men bara 18 V vid lasten när strömmen är 3 A. Källans anslutningar ligger kvar på 24 V. Beräkna extra serieresistans.</a:t>
+              <a:t>Matningen mäts till 24 V utan last men bara 18 V vid lasten när strömmen är 3 A. Källans anslutningar ligger kvar på 24 V. Beräkna extra serieresistans.</a:t>
             </a:r>
           </a:p>
         </p:txBody>
@@ -11108,6 +11563,30 @@
           </a:p>
         </p:txBody>
       </p:sp>
+      <p:pic xmlns:a="http://schemas.openxmlformats.org/drawingml/2006/main" xmlns:r="http://schemas.openxmlformats.org/officeDocument/2006/relationships">
+        <p:nvPicPr>
+          <p:cNvPr id="9" name="Figur: Källan håller 24 V, lasten får 18 V vid " descr="Källan håller 24 V, lasten får 18 V vid 3 A; den extra serieresistansen okänd"/>
+          <p:cNvPicPr>
+            <a:picLocks noChangeAspect="1"/>
+          </p:cNvPicPr>
+          <p:nvPr/>
+        </p:nvPicPr>
+        <p:blipFill>
+          <a:blip r:embed="rId3"/>
+          <a:stretch>
+            <a:fillRect/>
+          </a:stretch>
+        </p:blipFill>
+        <p:spPr>
+          <a:xfrm>
+            <a:off x="4846320" y="2331720"/>
+            <a:ext cx="3931920" cy="2740984"/>
+          </a:xfrm>
+          <a:prstGeom prst="rect">
+            <a:avLst/>
+          </a:prstGeom>
+        </p:spPr>
+      </p:pic>
     </p:spTree>
     <p:extLst>
       <p:ext uri="{BB962C8B-B14F-4D97-AF65-F5344CB8AC3E}">
@@ -11320,7 +11799,7 @@
                 <a:ea typeface="Calibri"/>
                 <a:cs typeface="Calibri"/>
               </a:rPr>
-              <a:t>Bristande källmatning påverkar matningen under belastning. En bruten hållväg visar sig särskilt efter START-släpp.</a:t>
+              <a:t>Vad förutsäger varje hypotes för källspänningen och spolspänningen, under START och efter släpp?</a:t>
             </a:r>
           </a:p>
         </p:txBody>
@@ -14437,64 +14916,6 @@
       </p:sp>
       <p:sp>
         <p:nvSpPr>
-          <p:cNvPr id="7" name="Källor och lärarstöd finns även i bildanteckningarna.">
-            <a:extLst xmlns:a="http://schemas.openxmlformats.org/drawingml/2006/main">
-              <a:ext uri="{FF2B5EF4-FFF2-40B4-BE49-F238E27FC236}">
-                <a16:creationId xmlns:a16="http://schemas.microsoft.com/office/drawing/2014/main" id="{B5ABF4AF-B1B4-49C4-A5A6-3CA9C29726B7}"/>
-              </a:ext>
-            </a:extLst>
-          </p:cNvPr>
-          <p:cNvSpPr>
-            <a:spLocks xmlns:a="http://schemas.openxmlformats.org/drawingml/2006/main" noGrp="1"/>
-          </p:cNvSpPr>
-          <p:nvPr/>
-        </p:nvSpPr>
-        <p:spPr>
-          <a:xfrm xmlns:a="http://schemas.openxmlformats.org/drawingml/2006/main">
-            <a:off x="762000" y="5676900"/>
-            <a:ext cx="7620000" cy="352425"/>
-          </a:xfrm>
-          <a:prstGeom xmlns:a="http://schemas.openxmlformats.org/drawingml/2006/main" prst="rect">
-            <a:avLst/>
-          </a:prstGeom>
-          <a:noFill xmlns:a="http://schemas.openxmlformats.org/drawingml/2006/main"/>
-          <a:ln xmlns:a="http://schemas.openxmlformats.org/drawingml/2006/main" w="0">
-            <a:noFill/>
-          </a:ln>
-        </p:spPr>
-        <p:txBody>
-          <a:bodyPr xmlns:a="http://schemas.openxmlformats.org/drawingml/2006/main" wrap="square" lIns="0" tIns="0" rIns="0" bIns="0" anchor="t">
-            <a:noAutofit/>
-          </a:bodyPr>
-          <a:lstStyle xmlns:a="http://schemas.openxmlformats.org/drawingml/2006/main"/>
-          <a:p xmlns:a="http://schemas.openxmlformats.org/drawingml/2006/main">
-            <a:pPr algn="l">
-              <a:buNone/>
-              <a:defRPr sz="1800" b="0">
-                <a:solidFill>
-                  <a:srgbClr val="111111"/>
-                </a:solidFill>
-                <a:latin typeface="Calibri"/>
-                <a:ea typeface="Calibri"/>
-                <a:cs typeface="Calibri"/>
-              </a:defRPr>
-            </a:pPr>
-            <a:r>
-              <a:rPr sz="1800" b="0">
-                <a:solidFill>
-                  <a:srgbClr val="111111"/>
-                </a:solidFill>
-                <a:latin typeface="Calibri"/>
-                <a:ea typeface="Calibri"/>
-                <a:cs typeface="Calibri"/>
-              </a:rPr>
-              <a:t>Källor och lärarstöd finns även i bildanteckningarna.</a:t>
-            </a:r>
-          </a:p>
-        </p:txBody>
-      </p:sp>
-      <p:sp>
-        <p:nvSpPr>
           <p:cNvPr id="8" name="22">
             <a:extLst xmlns:a="http://schemas.openxmlformats.org/drawingml/2006/main">
               <a:ext uri="{FF2B5EF4-FFF2-40B4-BE49-F238E27FC236}">
@@ -16353,7 +16774,7 @@
         <p:spPr>
           <a:xfrm xmlns:a="http://schemas.openxmlformats.org/drawingml/2006/main">
             <a:off x="762000" y="1619250"/>
-            <a:ext cx="7620000" cy="1466850"/>
+            <a:ext cx="3977639" cy="1466850"/>
           </a:xfrm>
           <a:prstGeom xmlns:a="http://schemas.openxmlformats.org/drawingml/2006/main" prst="rect">
             <a:avLst/>
@@ -16381,7 +16802,7 @@
               </a:defRPr>
             </a:pPr>
             <a:r>
-              <a:rPr sz="2400" b="0">
+              <a:rPr sz="1900" b="0">
                 <a:solidFill>
                   <a:srgbClr val="111111"/>
                 </a:solidFill>
@@ -16405,7 +16826,7 @@
               </a:defRPr>
             </a:pPr>
             <a:r>
-              <a:rPr sz="2400" b="0">
+              <a:rPr sz="1900" b="0">
                 <a:solidFill>
                   <a:srgbClr val="111111"/>
                 </a:solidFill>
@@ -16435,7 +16856,7 @@
         <p:spPr>
           <a:xfrm xmlns:a="http://schemas.openxmlformats.org/drawingml/2006/main">
             <a:off x="762000" y="3200400"/>
-            <a:ext cx="7620000" cy="838200"/>
+            <a:ext cx="3977639" cy="838200"/>
           </a:xfrm>
           <a:prstGeom xmlns:a="http://schemas.openxmlformats.org/drawingml/2006/main" prst="rect">
             <a:avLst/>
@@ -16463,7 +16884,7 @@
               </a:defRPr>
             </a:pPr>
             <a:r>
-              <a:rPr sz="2925" b="1">
+              <a:rPr sz="2650" b="1">
                 <a:solidFill>
                   <a:srgbClr val="064F91"/>
                 </a:solidFill>
@@ -16493,7 +16914,7 @@
         <p:spPr>
           <a:xfrm xmlns:a="http://schemas.openxmlformats.org/drawingml/2006/main">
             <a:off x="762000" y="4429125"/>
-            <a:ext cx="7620000" cy="1352550"/>
+            <a:ext cx="3977639" cy="1352550"/>
           </a:xfrm>
           <a:prstGeom xmlns:a="http://schemas.openxmlformats.org/drawingml/2006/main" prst="rect">
             <a:avLst/>
@@ -16521,7 +16942,7 @@
               </a:defRPr>
             </a:pPr>
             <a:r>
-              <a:rPr sz="2250" b="0">
+              <a:rPr sz="1900" b="0">
                 <a:solidFill>
                   <a:srgbClr val="111111"/>
                 </a:solidFill>
@@ -16545,7 +16966,7 @@
               </a:defRPr>
             </a:pPr>
             <a:r>
-              <a:rPr sz="2250" b="0">
+              <a:rPr sz="1900" b="0">
                 <a:solidFill>
                   <a:srgbClr val="111111"/>
                 </a:solidFill>
@@ -16616,6 +17037,30 @@
           </a:p>
         </p:txBody>
       </p:sp>
+      <p:pic xmlns:a="http://schemas.openxmlformats.org/drawingml/2006/main" xmlns:r="http://schemas.openxmlformats.org/officeDocument/2006/relationships">
+        <p:nvPicPr>
+          <p:cNvPr id="9" name="Figur: Matningskedja med mätpunkterna A till E " descr="Matningskedja med mätpunkterna A till E mellan källa och last; den första mätningen görs i mitten vid C"/>
+          <p:cNvPicPr>
+            <a:picLocks noChangeAspect="1"/>
+          </p:cNvPicPr>
+          <p:nvPr/>
+        </p:nvPicPr>
+        <p:blipFill>
+          <a:blip r:embed="rId3"/>
+          <a:stretch>
+            <a:fillRect/>
+          </a:stretch>
+        </p:blipFill>
+        <p:spPr>
+          <a:xfrm>
+            <a:off x="4892040" y="1645920"/>
+            <a:ext cx="3886200" cy="2528021"/>
+          </a:xfrm>
+          <a:prstGeom prst="rect">
+            <a:avLst/>
+          </a:prstGeom>
+        </p:spPr>
+      </p:pic>
     </p:spTree>
     <p:extLst>
       <p:ext uri="{BB962C8B-B14F-4D97-AF65-F5344CB8AC3E}">

</xml_diff>